<commit_message>
Guia compacta de 19 paginas, anexo de 13 y texto impersonal
Reestructura la guia: marco conceptual, metodologia, procedimiento, 10 ejercicios, anexo de 49 comandos, resultados y conclusiones. Reduce el anexo tecnico a una ficha por ejercicio con captura real de cierre. Neutraliza el tono del mapa, la presentacion y la galeria. Actualiza el README.
</commit_message>
<xml_diff>
--- a/Conflictos-Git-Presentacion.pptx
+++ b/Conflictos-Git-Presentacion.pptx
@@ -156,7 +156,7 @@
     </p:spTree>
     <p:extLst>
       <p:ext uri="{BB962C8B-B14F-4D97-AF65-F5344CB8AC3E}">
-        <p14:creationId xmlns:p14="http://schemas.microsoft.com/office/powerpoint/2010/main" val="3603703176"/>
+        <p14:creationId xmlns:p14="http://schemas.microsoft.com/office/powerpoint/2010/main" val="1782626772"/>
       </p:ext>
     </p:extLst>
   </p:cSld>
@@ -7450,7 +7450,7 @@
                 <a:ea typeface="Segoe UI" pitchFamily="34" charset="-122"/>
                 <a:cs typeface="Segoe UI" pitchFamily="34" charset="-120"/>
               </a:rPr>
-              <a:t>Si necesitas conservar las dos versiones, renombra una antes de integrar. Git no va a inventar una combinación.</a:t>
+              <a:t>Si deben conservarse las dos versiones, se renombra una antes de integrar. Git no genera una combinación.</a:t>
             </a:r>
             <a:endParaRPr lang="en-US" sz="1100" dirty="0"/>
           </a:p>
@@ -8684,7 +8684,7 @@
                 <a:ea typeface="Segoe UI" pitchFamily="34" charset="-122"/>
                 <a:cs typeface="Segoe UI" pitchFamily="34" charset="-120"/>
               </a:rPr>
-              <a:t>Tu commit se reaplica sobre otra base. Si choca, se detiene.</a:t>
+              <a:t>El commit se reaplica sobre otra base. Si choca, la operación se detiene.</a:t>
             </a:r>
             <a:endParaRPr lang="en-US" sz="1250" dirty="0"/>
           </a:p>
@@ -9014,7 +9014,7 @@
                 <a:ea typeface="Consolas" pitchFamily="34" charset="-122"/>
                 <a:cs typeface="Consolas" pitchFamily="34" charset="-120"/>
               </a:rPr>
-              <a:t>$ git show :3:version.txt   # tu commit</a:t>
+              <a:t>$ git show :3:version.txt   # commit propio</a:t>
             </a:r>
             <a:endParaRPr lang="en-US" sz="920" dirty="0"/>
           </a:p>
@@ -9176,7 +9176,7 @@
                 <a:ea typeface="Segoe UI" pitchFamily="34" charset="-122"/>
                 <a:cs typeface="Segoe UI" pitchFamily="34" charset="-120"/>
               </a:rPr>
-              <a:t>En rebase, ours = base y theirs = tu commit. La etiqueta “ours” no significa “mi versión”.</a:t>
+              <a:t>En rebase, ours = base y theirs = commit propio. La etiqueta «ours» no equivale a «versión propia».</a:t>
             </a:r>
             <a:endParaRPr lang="en-US" sz="1050" dirty="0"/>
           </a:p>
@@ -14084,7 +14084,7 @@
                 <a:ea typeface="Segoe UI" pitchFamily="34" charset="-122"/>
                 <a:cs typeface="Segoe UI" pitchFamily="34" charset="-120"/>
               </a:rPr>
-              <a:t>Si pop conflictúa, el stash NO se elimina. Primero resuelves, luego haces drop y commit.</a:t>
+              <a:t>Si pop genera conflicto, el stash NO se elimina. Primero se resuelve; después, drop y commit.</a:t>
             </a:r>
             <a:endParaRPr lang="en-US" sz="1050" dirty="0"/>
           </a:p>
@@ -15589,7 +15589,7 @@
                 <a:ea typeface="Segoe UI" pitchFamily="34" charset="-122"/>
                 <a:cs typeface="Segoe UI" pitchFamily="34" charset="-120"/>
               </a:rPr>
-              <a:t>Tu rama actual</a:t>
+              <a:t>Rama actual</a:t>
             </a:r>
             <a:endParaRPr lang="en-US" sz="850" dirty="0"/>
           </a:p>
@@ -15755,7 +15755,7 @@
                 <a:ea typeface="Segoe UI" pitchFamily="34" charset="-122"/>
                 <a:cs typeface="Segoe UI" pitchFamily="34" charset="-120"/>
               </a:rPr>
-              <a:t>La otra rama</a:t>
+              <a:t>Rama que se integra</a:t>
             </a:r>
             <a:endParaRPr lang="en-US" sz="850" dirty="0"/>
           </a:p>
@@ -17529,7 +17529,7 @@
                 <a:ea typeface="Segoe UI" pitchFamily="34" charset="-122"/>
                 <a:cs typeface="Segoe UI" pitchFamily="34" charset="-120"/>
               </a:rPr>
-              <a:t>Riesgo: pierdes hunks de la otra rama sin aviso.</a:t>
+              <a:t>Riesgo: se pierden hunks de la otra rama sin aviso.</a:t>
             </a:r>
             <a:endParaRPr lang="en-US" sz="850" dirty="0"/>
           </a:p>
@@ -17651,7 +17651,7 @@
                 <a:ea typeface="Segoe UI" pitchFamily="34" charset="-122"/>
                 <a:cs typeface="Segoe UI" pitchFamily="34" charset="-120"/>
               </a:rPr>
-              <a:t>Crea un merge commit cuyo árbol es idéntico al de tu rama. Ignora todo el árbol de la otra.</a:t>
+              <a:t>Crea un merge commit cuyo árbol es idéntico al de la rama actual. Ignora todo el árbol de la otra.</a:t>
             </a:r>
             <a:endParaRPr lang="en-US" sz="950" dirty="0"/>
           </a:p>
@@ -17695,7 +17695,7 @@
                 <a:ea typeface="Segoe UI" pitchFamily="34" charset="-122"/>
                 <a:cs typeface="Segoe UI" pitchFamily="34" charset="-120"/>
               </a:rPr>
-              <a:t>Riesgo: descartas la otra rama por completo.</a:t>
+              <a:t>Riesgo: se descarta la otra rama por completo.</a:t>
             </a:r>
             <a:endParaRPr lang="en-US" sz="850" dirty="0"/>
           </a:p>
@@ -19063,7 +19063,7 @@
                 <a:ea typeface="Segoe UI" pitchFamily="34" charset="-122"/>
                 <a:cs typeface="Segoe UI" pitchFamily="34" charset="-120"/>
               </a:rPr>
-              <a:t>4. repites el merge</a:t>
+              <a:t>4. se repite el merge</a:t>
             </a:r>
             <a:endParaRPr lang="en-US" sz="1000" dirty="0"/>
           </a:p>
@@ -20683,12 +20683,12 @@
         </p:nvSpPr>
         <p:spPr>
           <a:xfrm>
-            <a:off x="502920" y="1600200"/>
-            <a:ext cx="11201400" cy="4663440"/>
+            <a:off x="502920" y="1856232"/>
+            <a:ext cx="11201400" cy="4114800"/>
           </a:xfrm>
           <a:prstGeom prst="roundRect">
             <a:avLst>
-              <a:gd name="adj" fmla="val 1176"/>
+              <a:gd name="adj" fmla="val 1333"/>
             </a:avLst>
           </a:prstGeom>
           <a:solidFill>
@@ -20725,7 +20725,7 @@
         </p:blipFill>
         <p:spPr>
           <a:xfrm>
-            <a:off x="658368" y="2246808"/>
+            <a:off x="658368" y="2402256"/>
             <a:ext cx="10881360" cy="3004464"/>
           </a:xfrm>
           <a:prstGeom prst="rect">
@@ -20741,7 +20741,7 @@
         </p:nvSpPr>
         <p:spPr>
           <a:xfrm>
-            <a:off x="594360" y="5943600"/>
+            <a:off x="594360" y="6035040"/>
             <a:ext cx="10424160" cy="228600"/>
           </a:xfrm>
           <a:prstGeom prst="rect">
@@ -21981,7 +21981,7 @@
                 <a:ea typeface="Segoe UI" pitchFamily="34" charset="-122"/>
                 <a:cs typeface="Segoe UI" pitchFamily="34" charset="-120"/>
               </a:rPr>
-              <a:t>Guía · PDF · PPT · 10 scripts · 10 logs · 23 capturas</a:t>
+              <a:t>Guía · PDF · PPT · 10 scripts · 10 logs · 51 capturas reales</a:t>
             </a:r>
             <a:endParaRPr lang="en-US" sz="950" dirty="0"/>
           </a:p>
@@ -22694,7 +22694,7 @@
                 <a:ea typeface="Segoe UI" pitchFamily="34" charset="-122"/>
                 <a:cs typeface="Segoe UI" pitchFamily="34" charset="-120"/>
               </a:rPr>
-              <a:t>Es una decisión que Git no puede tomar por ti.</a:t>
+              <a:t>Es una decisión que Git no puede tomar.</a:t>
             </a:r>
             <a:endParaRPr lang="en-US" sz="1250" dirty="0"/>
           </a:p>
@@ -25754,7 +25754,7 @@
                 <a:ea typeface="Segoe UI" pitchFamily="34" charset="-122"/>
                 <a:cs typeface="Segoe UI" pitchFamily="34" charset="-120"/>
               </a:rPr>
-              <a:t>Guía · PDF · PPT · 10 scripts · 10 logs · 23 capturas</a:t>
+              <a:t>Guía · PDF · PPT · 10 scripts · 10 logs · 51 capturas reales</a:t>
             </a:r>
             <a:endParaRPr lang="en-US" sz="900" dirty="0"/>
           </a:p>
@@ -26467,7 +26467,7 @@
                 <a:ea typeface="Segoe UI" pitchFamily="34" charset="-122"/>
                 <a:cs typeface="Segoe UI" pitchFamily="34" charset="-120"/>
               </a:rPr>
-              <a:t>El archivo te muestra las tres versiones. No borres a ciegas.</a:t>
+              <a:t>El archivo muestra las tres versiones. No conviene borrar a ciegas.</a:t>
             </a:r>
             <a:endParaRPr lang="en-US" sz="1250" dirty="0"/>
           </a:p>
@@ -27079,7 +27079,7 @@
                 <a:ea typeface="Segoe UI" pitchFamily="34" charset="-122"/>
                 <a:cs typeface="Segoe UI" pitchFamily="34" charset="-120"/>
               </a:rPr>
-              <a:t>ours: tu rama actual</a:t>
+              <a:t>ours: rama actual</a:t>
             </a:r>
             <a:endParaRPr lang="en-US" sz="850" dirty="0"/>
           </a:p>
@@ -27445,7 +27445,7 @@
                 <a:ea typeface="Segoe UI" pitchFamily="34" charset="-122"/>
                 <a:cs typeface="Segoe UI" pitchFamily="34" charset="-120"/>
               </a:rPr>
-              <a:t>theirs: la otra rama</a:t>
+              <a:t>theirs: rama que se integra</a:t>
             </a:r>
             <a:endParaRPr lang="en-US" sz="850" dirty="0"/>
           </a:p>
@@ -27489,7 +27489,7 @@
                 <a:ea typeface="Segoe UI" pitchFamily="34" charset="-122"/>
                 <a:cs typeface="Segoe UI" pitchFamily="34" charset="-120"/>
               </a:rPr>
-              <a:t>Con merge.conflictStyle=zdiff3 también ves la base, y entiendes qué cambió cada lado.</a:t>
+              <a:t>Con merge.conflictStyle=zdiff3 también se ve la base y queda claro qué cambió cada lado.</a:t>
             </a:r>
             <a:endParaRPr lang="en-US" sz="1000" dirty="0"/>
           </a:p>
@@ -28779,12 +28779,12 @@
         </p:nvSpPr>
         <p:spPr>
           <a:xfrm>
-            <a:off x="502920" y="1645920"/>
-            <a:ext cx="11201400" cy="4572000"/>
+            <a:off x="502920" y="1874520"/>
+            <a:ext cx="11201400" cy="4343400"/>
           </a:xfrm>
           <a:prstGeom prst="roundRect">
             <a:avLst>
-              <a:gd name="adj" fmla="val 1200"/>
+              <a:gd name="adj" fmla="val 1263"/>
             </a:avLst>
           </a:prstGeom>
           <a:solidFill>
@@ -28821,8 +28821,8 @@
         </p:blipFill>
         <p:spPr>
           <a:xfrm>
-            <a:off x="2137595" y="1783080"/>
-            <a:ext cx="7922907" cy="4251960"/>
+            <a:off x="2307980" y="1920240"/>
+            <a:ext cx="7582137" cy="4069080"/>
           </a:xfrm>
           <a:prstGeom prst="rect">
             <a:avLst/>
@@ -28837,7 +28837,7 @@
         </p:nvSpPr>
         <p:spPr>
           <a:xfrm>
-            <a:off x="594360" y="6309360"/>
+            <a:off x="594360" y="6053328"/>
             <a:ext cx="10241280" cy="228600"/>
           </a:xfrm>
           <a:prstGeom prst="rect">
@@ -29492,7 +29492,7 @@
                 <a:ea typeface="Segoe UI" pitchFamily="34" charset="-122"/>
                 <a:cs typeface="Segoe UI" pitchFamily="34" charset="-120"/>
               </a:rPr>
-              <a:t>Los estados que debes reconocer</a:t>
+              <a:t>Los estados que deben reconocerse</a:t>
             </a:r>
             <a:endParaRPr lang="en-US" sz="2900" dirty="0"/>
           </a:p>
@@ -29536,7 +29536,7 @@
                 <a:ea typeface="Segoe UI" pitchFamily="34" charset="-122"/>
                 <a:cs typeface="Segoe UI" pitchFamily="34" charset="-120"/>
               </a:rPr>
-              <a:t>git status --short es tu primer diagnóstico.</a:t>
+              <a:t>git status --short es el primer diagnóstico.</a:t>
             </a:r>
             <a:endParaRPr lang="en-US" sz="1250" dirty="0"/>
           </a:p>
@@ -35449,7 +35449,7 @@
                 <a:ea typeface="Segoe UI" pitchFamily="34" charset="-122"/>
                 <a:cs typeface="Segoe UI" pitchFamily="34" charset="-120"/>
               </a:rPr>
-              <a:t>En un merge, ours eres tú. En un rebase, ours es la base.</a:t>
+              <a:t>En un merge, ours es la rama actual. En un rebase, ours es la base.</a:t>
             </a:r>
             <a:endParaRPr lang="en-US" sz="1250" dirty="0"/>
           </a:p>
@@ -35603,7 +35603,7 @@
                 <a:ea typeface="Segoe UI" pitchFamily="34" charset="-122"/>
                 <a:cs typeface="Segoe UI" pitchFamily="34" charset="-120"/>
               </a:rPr>
-              <a:t>ours = tu rama actual (HEAD)</a:t>
+              <a:t>ours = rama actual (HEAD)</a:t>
             </a:r>
             <a:endParaRPr lang="en-US" sz="1000" dirty="0"/>
           </a:p>
@@ -35623,7 +35623,7 @@
                 <a:ea typeface="Segoe UI" pitchFamily="34" charset="-122"/>
                 <a:cs typeface="Segoe UI" pitchFamily="34" charset="-120"/>
               </a:rPr>
-              <a:t>theirs = la rama que integras</a:t>
+              <a:t>theirs = rama que se integra</a:t>
             </a:r>
             <a:endParaRPr lang="en-US" sz="1000" dirty="0"/>
           </a:p>
@@ -35806,7 +35806,7 @@
                 <a:ea typeface="Segoe UI" pitchFamily="34" charset="-122"/>
                 <a:cs typeface="Segoe UI" pitchFamily="34" charset="-120"/>
               </a:rPr>
-              <a:t>ours = la rama base (upstream)</a:t>
+              <a:t>ours = rama base (upstream)</a:t>
             </a:r>
             <a:endParaRPr lang="en-US" sz="1000" dirty="0"/>
           </a:p>
@@ -35826,7 +35826,7 @@
                 <a:ea typeface="Segoe UI" pitchFamily="34" charset="-122"/>
                 <a:cs typeface="Segoe UI" pitchFamily="34" charset="-120"/>
               </a:rPr>
-              <a:t>theirs = tu commit que se reaplica</a:t>
+              <a:t>theirs = commit que se reaplica</a:t>
             </a:r>
             <a:endParaRPr lang="en-US" sz="1000" dirty="0"/>
           </a:p>
@@ -35855,7 +35855,7 @@
                 <a:ea typeface="Segoe UI" pitchFamily="34" charset="-122"/>
                 <a:cs typeface="Segoe UI" pitchFamily="34" charset="-120"/>
               </a:rPr>
-              <a:t>:2: = base   ·   :3: = tu commit</a:t>
+              <a:t>:2: = base   ·   :3: = commit reaplicado</a:t>
             </a:r>
             <a:endParaRPr lang="en-US" sz="1000" dirty="0"/>
           </a:p>
@@ -35977,7 +35977,7 @@
                 <a:ea typeface="Segoe UI" pitchFamily="34" charset="-122"/>
                 <a:cs typeface="Segoe UI" pitchFamily="34" charset="-120"/>
               </a:rPr>
-              <a:t>Si usas --ours en un rebase, conservas la base y puedes perder el cambio que estabas reaplicando. No es “mi versión”: es la versión de la base.</a:t>
+              <a:t>Si se usa --ours en un rebase, se conserva la base y puede perderse el cambio que se estaba reaplicando. No es “mi versión”: es la versión de la base.</a:t>
             </a:r>
             <a:endParaRPr lang="en-US" sz="1050" dirty="0"/>
           </a:p>

</xml_diff>